<commit_message>
Update final slide: clean thank you layout
</commit_message>
<xml_diff>
--- a/StockMaster_Final_Review_Presentation.pptx
+++ b/StockMaster_Final_Review_Presentation.pptx
@@ -12965,59 +12965,14 @@
       </p:sp>
       <p:sp>
         <p:nvSpPr>
-          <p:cNvPr id="4" name="Rounded Rectangle 3"/>
-          <p:cNvSpPr/>
-          <p:nvPr/>
-        </p:nvSpPr>
-        <p:spPr>
-          <a:xfrm>
-            <a:off x="1371600" y="1280160"/>
-            <a:ext cx="9448495" cy="4297680"/>
-          </a:xfrm>
-          <a:prstGeom prst="roundRect">
-            <a:avLst/>
-          </a:prstGeom>
-          <a:solidFill>
-            <a:srgbClr val="FFFFFF"/>
-          </a:solidFill>
-          <a:ln w="12700">
-            <a:solidFill>
-              <a:srgbClr val="1E3A8A"/>
-            </a:solidFill>
-          </a:ln>
-        </p:spPr>
-        <p:style>
-          <a:lnRef idx="1">
-            <a:schemeClr val="accent1"/>
-          </a:lnRef>
-          <a:fillRef idx="3">
-            <a:schemeClr val="accent1"/>
-          </a:fillRef>
-          <a:effectRef idx="2">
-            <a:schemeClr val="accent1"/>
-          </a:effectRef>
-          <a:fontRef idx="minor">
-            <a:schemeClr val="lt1"/>
-          </a:fontRef>
-        </p:style>
-        <p:txBody>
-          <a:bodyPr rtlCol="0" anchor="ctr"/>
-          <a:lstStyle/>
-          <a:p>
-            <a:pPr algn="ctr"/>
-          </a:p>
-        </p:txBody>
-      </p:sp>
-      <p:sp>
-        <p:nvSpPr>
-          <p:cNvPr id="5" name="TextBox 4"/>
+          <p:cNvPr id="4" name="TextBox 3"/>
           <p:cNvSpPr txBox="1"/>
           <p:nvPr/>
         </p:nvSpPr>
         <p:spPr>
           <a:xfrm>
-            <a:off x="1645920" y="1554480"/>
-            <a:ext cx="8899855" cy="3749039"/>
+            <a:off x="914400" y="2560320"/>
+            <a:ext cx="10362895" cy="1645920"/>
           </a:xfrm>
           <a:prstGeom prst="rect">
             <a:avLst/>
@@ -13031,7 +12986,7 @@
           <a:lstStyle/>
           <a:p>
             <a:pPr algn="ctr">
-              <a:defRPr sz="3600" b="1">
+              <a:defRPr sz="5400" b="1">
                 <a:solidFill>
                   <a:srgbClr val="1E3A8A"/>
                 </a:solidFill>
@@ -13039,83 +12994,7 @@
               </a:defRPr>
             </a:pPr>
             <a:r>
-              <a:t>STOCK MASTER</a:t>
-            </a:r>
-          </a:p>
-          <a:p>
-            <a:pPr algn="ctr">
-              <a:spcBef>
-                <a:spcPts val="400"/>
-              </a:spcBef>
-              <a:defRPr sz="1500">
-                <a:solidFill>
-                  <a:srgbClr val="2563EB"/>
-                </a:solidFill>
-                <a:latin typeface="Calibri"/>
-              </a:defRPr>
-            </a:pPr>
-            <a:r>
-              <a:t>Enterprise Multi-Warehouse Inventory &amp; Supply Chain Management System</a:t>
-            </a:r>
-          </a:p>
-          <a:p>
-            <a:pPr algn="ctr">
-              <a:spcBef>
-                <a:spcPts val="1600"/>
-              </a:spcBef>
-              <a:defRPr sz="3200" b="1">
-                <a:solidFill>
-                  <a:srgbClr val="1E3A8A"/>
-                </a:solidFill>
-              </a:defRPr>
-            </a:pPr>
-            <a:r>
-              <a:t>THANK YOU!</a:t>
-            </a:r>
-          </a:p>
-          <a:p>
-            <a:pPr algn="ctr">
-              <a:spcBef>
-                <a:spcPts val="600"/>
-              </a:spcBef>
-              <a:defRPr sz="1400" b="1">
-                <a:solidFill>
-                  <a:srgbClr val="0F172A"/>
-                </a:solidFill>
-              </a:defRPr>
-            </a:pPr>
-            <a:r>
-              <a:t>Open for Questions, Evaluation &amp; System Defense</a:t>
-            </a:r>
-          </a:p>
-          <a:p>
-            <a:pPr algn="ctr">
-              <a:spcBef>
-                <a:spcPts val="1400"/>
-              </a:spcBef>
-              <a:defRPr sz="1100">
-                <a:solidFill>
-                  <a:srgbClr val="64748B"/>
-                </a:solidFill>
-              </a:defRPr>
-            </a:pPr>
-            <a:r>
-              <a:t>Tech Stack: SQLite3 Relational DBMS • Python Flask REST APIs • Vanilla ES6+ Web Client • Active Triggers &amp; Views</a:t>
-            </a:r>
-          </a:p>
-          <a:p>
-            <a:pPr algn="ctr">
-              <a:spcBef>
-                <a:spcPts val="800"/>
-              </a:spcBef>
-              <a:defRPr sz="1100" b="1">
-                <a:solidFill>
-                  <a:srgbClr val="2563EB"/>
-                </a:solidFill>
-              </a:defRPr>
-            </a:pPr>
-            <a:r>
-              <a:t>Department of Artificial Intelligence • Amrita Vishwa Vidyapeetham, Coimbatore, India • Batch B • Group 18</a:t>
+              <a:t>THANK YOU</a:t>
             </a:r>
           </a:p>
         </p:txBody>

</xml_diff>

<commit_message>
Underline primary keys across presentation slides, relational schema, and project report
</commit_message>
<xml_diff>
--- a/StockMaster_Final_Review_Presentation.pptx
+++ b/StockMaster_Final_Review_Presentation.pptx
@@ -3830,7 +3830,7 @@
                         </a:defRPr>
                       </a:pPr>
                       <a:r>
-                        <a:t>Candidate Keys</a:t>
+                        <a:t>Candidate Keys (PK Underlined)</a:t>
                       </a:r>
                     </a:p>
                   </a:txBody>
@@ -3917,14 +3917,23 @@
                     <a:lstStyle/>
                     <a:p>
                       <a:pPr>
-                        <a:defRPr sz="1000" b="1">
+                        <a:defRPr sz="1000"/>
+                      </a:pPr>
+                      <a:r>
+                        <a:rPr b="1" u="sng">
+                          <a:solidFill>
+                            <a:srgbClr val="1E3A8A"/>
+                          </a:solidFill>
+                        </a:rPr>
+                        <a:t>UserID</a:t>
+                      </a:r>
+                      <a:r>
+                        <a:rPr b="0" u="none">
                           <a:solidFill>
                             <a:srgbClr val="0F172A"/>
                           </a:solidFill>
-                        </a:defRPr>
-                      </a:pPr>
-                      <a:r>
-                        <a:t>UserID; Email</a:t>
+                        </a:rPr>
+                        <a:t> ; Email</a:t>
                       </a:r>
                     </a:p>
                   </a:txBody>
@@ -4011,14 +4020,23 @@
                     <a:lstStyle/>
                     <a:p>
                       <a:pPr>
-                        <a:defRPr sz="1000" b="1">
+                        <a:defRPr sz="1000"/>
+                      </a:pPr>
+                      <a:r>
+                        <a:rPr b="1" u="sng">
+                          <a:solidFill>
+                            <a:srgbClr val="1E3A8A"/>
+                          </a:solidFill>
+                        </a:rPr>
+                        <a:t>SupplierID</a:t>
+                      </a:r>
+                      <a:r>
+                        <a:rPr b="0" u="none">
                           <a:solidFill>
                             <a:srgbClr val="0F172A"/>
                           </a:solidFill>
-                        </a:defRPr>
-                      </a:pPr>
-                      <a:r>
-                        <a:t>SupplierID; Email</a:t>
+                        </a:rPr>
+                        <a:t> ; Email</a:t>
                       </a:r>
                     </a:p>
                   </a:txBody>
@@ -4105,13 +4123,14 @@
                     <a:lstStyle/>
                     <a:p>
                       <a:pPr>
-                        <a:defRPr sz="1000" b="1">
-                          <a:solidFill>
-                            <a:srgbClr val="0F172A"/>
-                          </a:solidFill>
-                        </a:defRPr>
+                        <a:defRPr sz="1000"/>
                       </a:pPr>
                       <a:r>
+                        <a:rPr b="1" u="sng">
+                          <a:solidFill>
+                            <a:srgbClr val="1E3A8A"/>
+                          </a:solidFill>
+                        </a:rPr>
                         <a:t>ProductID</a:t>
                       </a:r>
                     </a:p>
@@ -4199,13 +4218,14 @@
                     <a:lstStyle/>
                     <a:p>
                       <a:pPr>
-                        <a:defRPr sz="1000" b="1">
-                          <a:solidFill>
-                            <a:srgbClr val="0F172A"/>
-                          </a:solidFill>
-                        </a:defRPr>
+                        <a:defRPr sz="1000"/>
                       </a:pPr>
                       <a:r>
+                        <a:rPr b="1" u="sng">
+                          <a:solidFill>
+                            <a:srgbClr val="1E3A8A"/>
+                          </a:solidFill>
+                        </a:rPr>
                         <a:t>WarehouseID</a:t>
                       </a:r>
                     </a:p>
@@ -4576,7 +4596,7 @@
                         </a:defRPr>
                       </a:pPr>
                       <a:r>
-                        <a:t>Candidate Keys</a:t>
+                        <a:t>Candidate Keys (PK Underlined)</a:t>
                       </a:r>
                     </a:p>
                   </a:txBody>
@@ -4663,14 +4683,23 @@
                     <a:lstStyle/>
                     <a:p>
                       <a:pPr>
-                        <a:defRPr sz="1000" b="1">
+                        <a:defRPr sz="1000"/>
+                      </a:pPr>
+                      <a:r>
+                        <a:rPr b="1" u="sng">
+                          <a:solidFill>
+                            <a:srgbClr val="1E3A8A"/>
+                          </a:solidFill>
+                        </a:rPr>
+                        <a:t>InventoryID</a:t>
+                      </a:r>
+                      <a:r>
+                        <a:rPr b="0" u="none">
                           <a:solidFill>
                             <a:srgbClr val="0F172A"/>
                           </a:solidFill>
-                        </a:defRPr>
-                      </a:pPr>
-                      <a:r>
-                        <a:t>InventoryID; (ProductID, WarehouseID)</a:t>
+                        </a:rPr>
+                        <a:t> ; (ProductID, WarehouseID)</a:t>
                       </a:r>
                     </a:p>
                   </a:txBody>
@@ -4757,13 +4786,14 @@
                     <a:lstStyle/>
                     <a:p>
                       <a:pPr>
-                        <a:defRPr sz="1000" b="1">
-                          <a:solidFill>
-                            <a:srgbClr val="0F172A"/>
-                          </a:solidFill>
-                        </a:defRPr>
+                        <a:defRPr sz="1000"/>
                       </a:pPr>
                       <a:r>
+                        <a:rPr b="1" u="sng">
+                          <a:solidFill>
+                            <a:srgbClr val="1E3A8A"/>
+                          </a:solidFill>
+                        </a:rPr>
                         <a:t>PurchaseOrderID</a:t>
                       </a:r>
                     </a:p>
@@ -4851,14 +4881,23 @@
                     <a:lstStyle/>
                     <a:p>
                       <a:pPr>
-                        <a:defRPr sz="1000" b="1">
+                        <a:defRPr sz="1000"/>
+                      </a:pPr>
+                      <a:r>
+                        <a:rPr b="1" u="sng">
+                          <a:solidFill>
+                            <a:srgbClr val="1E3A8A"/>
+                          </a:solidFill>
+                        </a:rPr>
+                        <a:t>ItemID</a:t>
+                      </a:r>
+                      <a:r>
+                        <a:rPr b="0" u="none">
                           <a:solidFill>
                             <a:srgbClr val="0F172A"/>
                           </a:solidFill>
-                        </a:defRPr>
-                      </a:pPr>
-                      <a:r>
-                        <a:t>ItemID; (PurchaseOrderID, ProductID)</a:t>
+                        </a:rPr>
+                        <a:t> ; (PurchaseOrderID, ProductID)</a:t>
                       </a:r>
                     </a:p>
                   </a:txBody>
@@ -4945,13 +4984,14 @@
                     <a:lstStyle/>
                     <a:p>
                       <a:pPr>
-                        <a:defRPr sz="1000" b="1">
-                          <a:solidFill>
-                            <a:srgbClr val="0F172A"/>
-                          </a:solidFill>
-                        </a:defRPr>
+                        <a:defRPr sz="1000"/>
                       </a:pPr>
                       <a:r>
+                        <a:rPr b="1" u="sng">
+                          <a:solidFill>
+                            <a:srgbClr val="1E3A8A"/>
+                          </a:solidFill>
+                        </a:rPr>
                         <a:t>SalesOrderID</a:t>
                       </a:r>
                     </a:p>
@@ -5322,7 +5362,7 @@
                         </a:defRPr>
                       </a:pPr>
                       <a:r>
-                        <a:t>Candidate Keys</a:t>
+                        <a:t>Candidate Keys (PK Underlined)</a:t>
                       </a:r>
                     </a:p>
                   </a:txBody>
@@ -5409,14 +5449,23 @@
                     <a:lstStyle/>
                     <a:p>
                       <a:pPr>
-                        <a:defRPr sz="1000" b="1">
+                        <a:defRPr sz="1000"/>
+                      </a:pPr>
+                      <a:r>
+                        <a:rPr b="1" u="sng">
+                          <a:solidFill>
+                            <a:srgbClr val="1E3A8A"/>
+                          </a:solidFill>
+                        </a:rPr>
+                        <a:t>ItemID</a:t>
+                      </a:r>
+                      <a:r>
+                        <a:rPr b="0" u="none">
                           <a:solidFill>
                             <a:srgbClr val="0F172A"/>
                           </a:solidFill>
-                        </a:defRPr>
-                      </a:pPr>
-                      <a:r>
-                        <a:t>ItemID; (SalesOrderID, ProductID)</a:t>
+                        </a:rPr>
+                        <a:t> ; (SalesOrderID, ProductID)</a:t>
                       </a:r>
                     </a:p>
                   </a:txBody>
@@ -5503,14 +5552,23 @@
                     <a:lstStyle/>
                     <a:p>
                       <a:pPr>
-                        <a:defRPr sz="1000" b="1">
+                        <a:defRPr sz="1000"/>
+                      </a:pPr>
+                      <a:r>
+                        <a:rPr b="1" u="sng">
+                          <a:solidFill>
+                            <a:srgbClr val="1E3A8A"/>
+                          </a:solidFill>
+                        </a:rPr>
+                        <a:t>ShipmentID</a:t>
+                      </a:r>
+                      <a:r>
+                        <a:rPr b="0" u="none">
                           <a:solidFill>
                             <a:srgbClr val="0F172A"/>
                           </a:solidFill>
-                        </a:defRPr>
-                      </a:pPr>
-                      <a:r>
-                        <a:t>ShipmentID; SalesOrderID</a:t>
+                        </a:rPr>
+                        <a:t> ; SalesOrderID</a:t>
                       </a:r>
                     </a:p>
                   </a:txBody>
@@ -5597,14 +5655,23 @@
                     <a:lstStyle/>
                     <a:p>
                       <a:pPr>
-                        <a:defRPr sz="1000" b="1">
+                        <a:defRPr sz="1000"/>
+                      </a:pPr>
+                      <a:r>
+                        <a:rPr b="1" u="sng">
+                          <a:solidFill>
+                            <a:srgbClr val="1E3A8A"/>
+                          </a:solidFill>
+                        </a:rPr>
+                        <a:t>BillID</a:t>
+                      </a:r>
+                      <a:r>
+                        <a:rPr b="0" u="none">
                           <a:solidFill>
                             <a:srgbClr val="0F172A"/>
                           </a:solidFill>
-                        </a:defRPr>
-                      </a:pPr>
-                      <a:r>
-                        <a:t>BillID; SalesOrderID</a:t>
+                        </a:rPr>
+                        <a:t> ; SalesOrderID</a:t>
                       </a:r>
                     </a:p>
                   </a:txBody>
@@ -17165,15 +17232,24 @@
               <a:spcBef>
                 <a:spcPts val="200"/>
               </a:spcBef>
-              <a:defRPr sz="950">
+            </a:pPr>
+            <a:r>
+              <a:rPr sz="950" b="1" u="sng">
+                <a:solidFill>
+                  <a:srgbClr val="1E3A8A"/>
+                </a:solidFill>
+                <a:latin typeface="Consolas"/>
+              </a:rPr>
+              <a:t>UserID</a:t>
+            </a:r>
+            <a:r>
+              <a:rPr sz="950" b="0" u="none">
                 <a:solidFill>
                   <a:srgbClr val="334155"/>
                 </a:solidFill>
                 <a:latin typeface="Consolas"/>
-              </a:defRPr>
-            </a:pPr>
-            <a:r>
-              <a:t>UserID [PK], Name, Email [UNIQUE], Password, Role</a:t>
+              </a:rPr>
+              <a:t> [PK], Name, Email [UNIQUE], Password, Role</a:t>
             </a:r>
           </a:p>
           <a:p>
@@ -17196,15 +17272,24 @@
               <a:spcBef>
                 <a:spcPts val="200"/>
               </a:spcBef>
-              <a:defRPr sz="950">
+            </a:pPr>
+            <a:r>
+              <a:rPr sz="950" b="1" u="sng">
+                <a:solidFill>
+                  <a:srgbClr val="1E3A8A"/>
+                </a:solidFill>
+                <a:latin typeface="Consolas"/>
+              </a:rPr>
+              <a:t>SupplierID</a:t>
+            </a:r>
+            <a:r>
+              <a:rPr sz="950" b="0" u="none">
                 <a:solidFill>
                   <a:srgbClr val="334155"/>
                 </a:solidFill>
                 <a:latin typeface="Consolas"/>
-              </a:defRPr>
-            </a:pPr>
-            <a:r>
-              <a:t>SupplierID [PK], SupplierName, Phone, Email [UNIQUE], Address</a:t>
+              </a:rPr>
+              <a:t> [PK], SupplierName, Phone, Email [UNIQUE], Address</a:t>
             </a:r>
           </a:p>
           <a:p>
@@ -17227,15 +17312,24 @@
               <a:spcBef>
                 <a:spcPts val="200"/>
               </a:spcBef>
-              <a:defRPr sz="950">
+            </a:pPr>
+            <a:r>
+              <a:rPr sz="950" b="1" u="sng">
+                <a:solidFill>
+                  <a:srgbClr val="1E3A8A"/>
+                </a:solidFill>
+                <a:latin typeface="Consolas"/>
+              </a:rPr>
+              <a:t>ProductID</a:t>
+            </a:r>
+            <a:r>
+              <a:rPr sz="950" b="0" u="none">
                 <a:solidFill>
                   <a:srgbClr val="334155"/>
                 </a:solidFill>
                 <a:latin typeface="Consolas"/>
-              </a:defRPr>
-            </a:pPr>
-            <a:r>
-              <a:t>ProductID [PK], ProductName, Description, Category, UnitPrice, SupplierID [FK]</a:t>
+              </a:rPr>
+              <a:t> [PK], ProductName, Description, Category, UnitPrice, SupplierID [FK]</a:t>
             </a:r>
           </a:p>
           <a:p>
@@ -17258,15 +17352,24 @@
               <a:spcBef>
                 <a:spcPts val="200"/>
               </a:spcBef>
-              <a:defRPr sz="950">
+            </a:pPr>
+            <a:r>
+              <a:rPr sz="950" b="1" u="sng">
+                <a:solidFill>
+                  <a:srgbClr val="1E3A8A"/>
+                </a:solidFill>
+                <a:latin typeface="Consolas"/>
+              </a:rPr>
+              <a:t>WarehouseID</a:t>
+            </a:r>
+            <a:r>
+              <a:rPr sz="950" b="0" u="none">
                 <a:solidFill>
                   <a:srgbClr val="334155"/>
                 </a:solidFill>
                 <a:latin typeface="Consolas"/>
-              </a:defRPr>
-            </a:pPr>
-            <a:r>
-              <a:t>WarehouseID [PK], WarehouseName, Location, Capacity</a:t>
+              </a:rPr>
+              <a:t> [PK], WarehouseName, Location, Capacity</a:t>
             </a:r>
           </a:p>
         </p:txBody>
@@ -17372,15 +17475,24 @@
               <a:spcBef>
                 <a:spcPts val="200"/>
               </a:spcBef>
-              <a:defRPr sz="950">
+            </a:pPr>
+            <a:r>
+              <a:rPr sz="950" b="1" u="sng">
+                <a:solidFill>
+                  <a:srgbClr val="1E3A8A"/>
+                </a:solidFill>
+                <a:latin typeface="Consolas"/>
+              </a:rPr>
+              <a:t>InventoryID</a:t>
+            </a:r>
+            <a:r>
+              <a:rPr sz="950" b="0" u="none">
                 <a:solidFill>
                   <a:srgbClr val="334155"/>
                 </a:solidFill>
                 <a:latin typeface="Consolas"/>
-              </a:defRPr>
-            </a:pPr>
-            <a:r>
-              <a:t>InventoryID [PK], ProductID [FK], WarehouseID [FK], Quantity, MinimumStock</a:t>
+              </a:rPr>
+              <a:t> [PK], ProductID [FK], WarehouseID [FK], Quantity, MinimumStock</a:t>
             </a:r>
           </a:p>
           <a:p>
@@ -17403,15 +17515,24 @@
               <a:spcBef>
                 <a:spcPts val="200"/>
               </a:spcBef>
-              <a:defRPr sz="950">
+            </a:pPr>
+            <a:r>
+              <a:rPr sz="950" b="1" u="sng">
+                <a:solidFill>
+                  <a:srgbClr val="1E3A8A"/>
+                </a:solidFill>
+                <a:latin typeface="Consolas"/>
+              </a:rPr>
+              <a:t>PurchaseOrderID</a:t>
+            </a:r>
+            <a:r>
+              <a:rPr sz="950" b="0" u="none">
                 <a:solidFill>
                   <a:srgbClr val="334155"/>
                 </a:solidFill>
                 <a:latin typeface="Consolas"/>
-              </a:defRPr>
-            </a:pPr>
-            <a:r>
-              <a:t>PurchaseOrderID [PK], SupplierID [FK], WarehouseID [FK], OrderDate, Status, TotalAmount</a:t>
+              </a:rPr>
+              <a:t> [PK], SupplierID [FK], WarehouseID [FK], OrderDate, Status, TotalAmount</a:t>
             </a:r>
           </a:p>
           <a:p>
@@ -17434,15 +17555,24 @@
               <a:spcBef>
                 <a:spcPts val="200"/>
               </a:spcBef>
-              <a:defRPr sz="950">
+            </a:pPr>
+            <a:r>
+              <a:rPr sz="950" b="1" u="sng">
+                <a:solidFill>
+                  <a:srgbClr val="1E3A8A"/>
+                </a:solidFill>
+                <a:latin typeface="Consolas"/>
+              </a:rPr>
+              <a:t>ItemID</a:t>
+            </a:r>
+            <a:r>
+              <a:rPr sz="950" b="0" u="none">
                 <a:solidFill>
                   <a:srgbClr val="334155"/>
                 </a:solidFill>
                 <a:latin typeface="Consolas"/>
-              </a:defRPr>
-            </a:pPr>
-            <a:r>
-              <a:t>ItemID [PK], PurchaseOrderID [FK], ProductID [FK], Quantity, UnitPrice</a:t>
+              </a:rPr>
+              <a:t> [PK], PurchaseOrderID [FK], ProductID [FK], Quantity, UnitPrice</a:t>
             </a:r>
           </a:p>
           <a:p>
@@ -17465,15 +17595,24 @@
               <a:spcBef>
                 <a:spcPts val="200"/>
               </a:spcBef>
-              <a:defRPr sz="950">
+            </a:pPr>
+            <a:r>
+              <a:rPr sz="950" b="1" u="sng">
+                <a:solidFill>
+                  <a:srgbClr val="1E3A8A"/>
+                </a:solidFill>
+                <a:latin typeface="Consolas"/>
+              </a:rPr>
+              <a:t>SalesOrderID</a:t>
+            </a:r>
+            <a:r>
+              <a:rPr sz="950" b="0" u="none">
                 <a:solidFill>
                   <a:srgbClr val="334155"/>
                 </a:solidFill>
                 <a:latin typeface="Consolas"/>
-              </a:defRPr>
-            </a:pPr>
-            <a:r>
-              <a:t>SalesOrderID [PK], CustomerName, WarehouseID [FK], OrderDate, Status, TotalAmount</a:t>
+              </a:rPr>
+              <a:t> [PK], CustomerName, WarehouseID [FK], OrderDate, Status, TotalAmount</a:t>
             </a:r>
           </a:p>
         </p:txBody>
@@ -17579,15 +17718,24 @@
               <a:spcBef>
                 <a:spcPts val="200"/>
               </a:spcBef>
-              <a:defRPr sz="950">
+            </a:pPr>
+            <a:r>
+              <a:rPr sz="950" b="1" u="sng">
+                <a:solidFill>
+                  <a:srgbClr val="1E3A8A"/>
+                </a:solidFill>
+                <a:latin typeface="Consolas"/>
+              </a:rPr>
+              <a:t>ItemID</a:t>
+            </a:r>
+            <a:r>
+              <a:rPr sz="950" b="0" u="none">
                 <a:solidFill>
                   <a:srgbClr val="334155"/>
                 </a:solidFill>
                 <a:latin typeface="Consolas"/>
-              </a:defRPr>
-            </a:pPr>
-            <a:r>
-              <a:t>ItemID [PK], SalesOrderID [FK], ProductID [FK], Quantity, UnitPrice</a:t>
+              </a:rPr>
+              <a:t> [PK], SalesOrderID [FK], ProductID [FK], Quantity, UnitPrice</a:t>
             </a:r>
           </a:p>
           <a:p>
@@ -17610,15 +17758,24 @@
               <a:spcBef>
                 <a:spcPts val="200"/>
               </a:spcBef>
-              <a:defRPr sz="950">
+            </a:pPr>
+            <a:r>
+              <a:rPr sz="950" b="1" u="sng">
+                <a:solidFill>
+                  <a:srgbClr val="1E3A8A"/>
+                </a:solidFill>
+                <a:latin typeface="Consolas"/>
+              </a:rPr>
+              <a:t>ShipmentID</a:t>
+            </a:r>
+            <a:r>
+              <a:rPr sz="950" b="0" u="none">
                 <a:solidFill>
                   <a:srgbClr val="334155"/>
                 </a:solidFill>
                 <a:latin typeface="Consolas"/>
-              </a:defRPr>
-            </a:pPr>
-            <a:r>
-              <a:t>ShipmentID [PK], SalesOrderID [FK, UNIQUE], WarehouseID [FK], ShipmentDate, Status</a:t>
+              </a:rPr>
+              <a:t> [PK], SalesOrderID [FK, UNIQUE], WarehouseID [FK], ShipmentDate, Status</a:t>
             </a:r>
           </a:p>
           <a:p>
@@ -17641,15 +17798,24 @@
               <a:spcBef>
                 <a:spcPts val="200"/>
               </a:spcBef>
-              <a:defRPr sz="950">
+            </a:pPr>
+            <a:r>
+              <a:rPr sz="950" b="1" u="sng">
+                <a:solidFill>
+                  <a:srgbClr val="1E3A8A"/>
+                </a:solidFill>
+                <a:latin typeface="Consolas"/>
+              </a:rPr>
+              <a:t>BillID</a:t>
+            </a:r>
+            <a:r>
+              <a:rPr sz="950" b="0" u="none">
                 <a:solidFill>
                   <a:srgbClr val="334155"/>
                 </a:solidFill>
                 <a:latin typeface="Consolas"/>
-              </a:defRPr>
-            </a:pPr>
-            <a:r>
-              <a:t>BillID [PK], SalesOrderID [FK, UNIQUE], Amount, PaymentMethod, PaymentStatus, PaymentDate</a:t>
+              </a:rPr>
+              <a:t> [PK], SalesOrderID [FK, UNIQUE], Amount, PaymentMethod, PaymentStatus, PaymentDate</a:t>
             </a:r>
           </a:p>
         </p:txBody>

</xml_diff>

<commit_message>
Refine normalization slide headings, text box layout wrapping, and report diagrams
</commit_message>
<xml_diff>
--- a/StockMaster_Final_Review_Presentation.pptx
+++ b/StockMaster_Final_Review_Presentation.pptx
@@ -3254,7 +3254,7 @@
           <a:noFill/>
         </p:spPr>
         <p:txBody>
-          <a:bodyPr wrap="none">
+          <a:bodyPr wrap="square">
             <a:spAutoFit/>
           </a:bodyPr>
           <a:lstStyle/>
@@ -3383,7 +3383,7 @@
           <a:noFill/>
         </p:spPr>
         <p:txBody>
-          <a:bodyPr wrap="none">
+          <a:bodyPr wrap="square">
             <a:spAutoFit/>
           </a:bodyPr>
           <a:lstStyle/>
@@ -3419,7 +3419,7 @@
           <a:noFill/>
         </p:spPr>
         <p:txBody>
-          <a:bodyPr wrap="none">
+          <a:bodyPr wrap="square">
             <a:spAutoFit/>
           </a:bodyPr>
           <a:lstStyle/>
@@ -3728,7 +3728,7 @@
               </a:defRPr>
             </a:pPr>
             <a:r>
-              <a:t>Database Normalization Analysis (Part 1: Core Master Entities)</a:t>
+              <a:t>Database Normalization: Master Entities</a:t>
             </a:r>
           </a:p>
         </p:txBody>
@@ -4494,7 +4494,7 @@
               </a:defRPr>
             </a:pPr>
             <a:r>
-              <a:t>Database Normalization Analysis (Part 2: Inventory &amp; Orders)</a:t>
+              <a:t>Database Normalization: Inventory &amp; Orders</a:t>
             </a:r>
           </a:p>
         </p:txBody>
@@ -5260,7 +5260,7 @@
               </a:defRPr>
             </a:pPr>
             <a:r>
-              <a:t>Database Normalization Analysis (Part 3: Line Items, Shipments &amp; Billing)</a:t>
+              <a:t>Database Normalization: Line Items, Shipments &amp; Billing</a:t>
             </a:r>
           </a:p>
         </p:txBody>
@@ -5740,7 +5740,7 @@
         </p:nvSpPr>
         <p:spPr>
           <a:xfrm>
-            <a:off x="731520" y="5166360"/>
+            <a:off x="731520" y="5120640"/>
             <a:ext cx="10728655" cy="1234440"/>
           </a:xfrm>
           <a:prstGeom prst="roundRect">
@@ -5785,8 +5785,8 @@
         </p:nvSpPr>
         <p:spPr>
           <a:xfrm>
-            <a:off x="914400" y="5230368"/>
-            <a:ext cx="10362895" cy="1005840"/>
+            <a:off x="914400" y="5193792"/>
+            <a:ext cx="10362895" cy="1097280"/>
           </a:xfrm>
           <a:prstGeom prst="rect">
             <a:avLst/>
@@ -5794,7 +5794,7 @@
           <a:noFill/>
         </p:spPr>
         <p:txBody>
-          <a:bodyPr wrap="none">
+          <a:bodyPr wrap="square" lIns="137160" rIns="137160" tIns="73152" bIns="73152">
             <a:spAutoFit/>
           </a:bodyPr>
           <a:lstStyle/>
@@ -5815,7 +5815,7 @@
               <a:spcBef>
                 <a:spcPts val="300"/>
               </a:spcBef>
-              <a:defRPr sz="1050">
+              <a:defRPr sz="1000">
                 <a:solidFill>
                   <a:srgbClr val="0F172A"/>
                 </a:solidFill>
@@ -9556,7 +9556,7 @@
           <a:noFill/>
         </p:spPr>
         <p:txBody>
-          <a:bodyPr wrap="none">
+          <a:bodyPr wrap="square">
             <a:spAutoFit/>
           </a:bodyPr>
           <a:lstStyle/>
@@ -9836,7 +9836,7 @@
           <a:noFill/>
         </p:spPr>
         <p:txBody>
-          <a:bodyPr wrap="none">
+          <a:bodyPr wrap="square">
             <a:spAutoFit/>
           </a:bodyPr>
           <a:lstStyle/>
@@ -12564,7 +12564,7 @@
           <a:noFill/>
         </p:spPr>
         <p:txBody>
-          <a:bodyPr wrap="none">
+          <a:bodyPr wrap="square">
             <a:spAutoFit/>
           </a:bodyPr>
           <a:lstStyle/>
@@ -12776,7 +12776,7 @@
           <a:noFill/>
         </p:spPr>
         <p:txBody>
-          <a:bodyPr wrap="none">
+          <a:bodyPr wrap="square">
             <a:spAutoFit/>
           </a:bodyPr>
           <a:lstStyle/>
@@ -15026,7 +15026,7 @@
           <a:noFill/>
         </p:spPr>
         <p:txBody>
-          <a:bodyPr wrap="none">
+          <a:bodyPr wrap="square">
             <a:spAutoFit/>
           </a:bodyPr>
           <a:lstStyle/>
@@ -15597,7 +15597,7 @@
           <a:noFill/>
         </p:spPr>
         <p:txBody>
-          <a:bodyPr wrap="none">
+          <a:bodyPr wrap="square">
             <a:spAutoFit/>
           </a:bodyPr>
           <a:lstStyle/>
@@ -16138,7 +16138,7 @@
           <a:noFill/>
         </p:spPr>
         <p:txBody>
-          <a:bodyPr wrap="none">
+          <a:bodyPr wrap="square">
             <a:spAutoFit/>
           </a:bodyPr>
           <a:lstStyle/>
@@ -16721,7 +16721,7 @@
           <a:noFill/>
         </p:spPr>
         <p:txBody>
-          <a:bodyPr wrap="none">
+          <a:bodyPr wrap="square">
             <a:spAutoFit/>
           </a:bodyPr>
           <a:lstStyle/>

</xml_diff>